<commit_message>
Ask page: no amount on stage (Nova) — round is 70% reusable infra + GTM; amount and allocation move to appendix A10; notes rewritten for the new privacy, rings and ask pages
</commit_message>
<xml_diff>
--- a/deck/Vishwa_Pitch_2026-09-09.pptx
+++ b/deck/Vishwa_Pitch_2026-09-09.pptx
@@ -25,6 +25,7 @@
     <p:sldId id="273" r:id="rId24"/>
     <p:sldId id="274" r:id="rId25"/>
     <p:sldId id="275" r:id="rId26"/>
+    <p:sldId id="276" r:id="rId27"/>
   </p:sldIdLst>
   <p:sldSz cx="12191695" cy="6858000" type="screen4x3"/>
   <p:notesSz cx="6858000" cy="9144000"/>
@@ -3643,6 +3644,48 @@
 </p:sld>
 </file>
 
+<file path=ppt/slides/slide21.xml><?xml version="1.0" encoding="utf-8"?>
+<p:sld xmlns:a="http://schemas.openxmlformats.org/drawingml/2006/main" xmlns:p="http://schemas.openxmlformats.org/presentationml/2006/main" xmlns:r="http://schemas.openxmlformats.org/officeDocument/2006/relationships">
+  <p:cSld>
+    <p:spTree>
+      <p:nvGrpSpPr>
+        <p:cNvPr id="1" name=""/>
+        <p:cNvGrpSpPr/>
+        <p:nvPr/>
+      </p:nvGrpSpPr>
+      <p:grpSpPr/>
+      <p:pic>
+        <p:nvPicPr>
+          <p:cNvPr id="2" name="Picture 1" descr="slide_21.png"/>
+          <p:cNvPicPr>
+            <a:picLocks noChangeAspect="1"/>
+          </p:cNvPicPr>
+          <p:nvPr/>
+        </p:nvPicPr>
+        <p:blipFill>
+          <a:blip r:embed="rId2"/>
+          <a:stretch>
+            <a:fillRect/>
+          </a:stretch>
+        </p:blipFill>
+        <p:spPr>
+          <a:xfrm>
+            <a:off x="0" y="0"/>
+            <a:ext cx="12191695" cy="6858000"/>
+          </a:xfrm>
+          <a:prstGeom prst="rect">
+            <a:avLst/>
+          </a:prstGeom>
+        </p:spPr>
+      </p:pic>
+    </p:spTree>
+  </p:cSld>
+  <p:clrMapOvr>
+    <a:masterClrMapping/>
+  </p:clrMapOvr>
+</p:sld>
+</file>
+
 <file path=ppt/slides/slide3.xml><?xml version="1.0" encoding="utf-8"?>
 <p:sld xmlns:a="http://schemas.openxmlformats.org/drawingml/2006/main" xmlns:p="http://schemas.openxmlformats.org/presentationml/2006/main" xmlns:r="http://schemas.openxmlformats.org/officeDocument/2006/relationships">
   <p:cSld>

</xml_diff>

<commit_message>
Slide 09: compute vertical leads (OpenEpoch oe11+oe13), Ant compressed to one row with updated 40M/20M; treasury overnight flow moves to appendix A11
</commit_message>
<xml_diff>
--- a/deck/Vishwa_Pitch_2026-09-09.pptx
+++ b/deck/Vishwa_Pitch_2026-09-09.pptx
@@ -26,6 +26,7 @@
     <p:sldId id="274" r:id="rId25"/>
     <p:sldId id="275" r:id="rId26"/>
     <p:sldId id="276" r:id="rId27"/>
+    <p:sldId id="277" r:id="rId28"/>
   </p:sldIdLst>
   <p:sldSz cx="12191695" cy="6858000" type="screen4x3"/>
   <p:notesSz cx="6858000" cy="9144000"/>
@@ -3657,6 +3658,48 @@
       <p:pic>
         <p:nvPicPr>
           <p:cNvPr id="2" name="Picture 1" descr="slide_21.png"/>
+          <p:cNvPicPr>
+            <a:picLocks noChangeAspect="1"/>
+          </p:cNvPicPr>
+          <p:nvPr/>
+        </p:nvPicPr>
+        <p:blipFill>
+          <a:blip r:embed="rId2"/>
+          <a:stretch>
+            <a:fillRect/>
+          </a:stretch>
+        </p:blipFill>
+        <p:spPr>
+          <a:xfrm>
+            <a:off x="0" y="0"/>
+            <a:ext cx="12191695" cy="6858000"/>
+          </a:xfrm>
+          <a:prstGeom prst="rect">
+            <a:avLst/>
+          </a:prstGeom>
+        </p:spPr>
+      </p:pic>
+    </p:spTree>
+  </p:cSld>
+  <p:clrMapOvr>
+    <a:masterClrMapping/>
+  </p:clrMapOvr>
+</p:sld>
+</file>
+
+<file path=ppt/slides/slide22.xml><?xml version="1.0" encoding="utf-8"?>
+<p:sld xmlns:a="http://schemas.openxmlformats.org/drawingml/2006/main" xmlns:p="http://schemas.openxmlformats.org/presentationml/2006/main" xmlns:r="http://schemas.openxmlformats.org/officeDocument/2006/relationships">
+  <p:cSld>
+    <p:spTree>
+      <p:nvGrpSpPr>
+        <p:cNvPr id="1" name=""/>
+        <p:cNvGrpSpPr/>
+        <p:nvPr/>
+      </p:nvGrpSpPr>
+      <p:grpSpPr/>
+      <p:pic>
+        <p:nvPicPr>
+          <p:cNvPr id="2" name="Picture 1" descr="slide_22.png"/>
           <p:cNvPicPr>
             <a:picLocks noChangeAspect="1"/>
           </p:cNvPicPr>

</xml_diff>